<commit_message>
update all pptx with red theme
</commit_message>
<xml_diff>
--- a/pptx/midterm/REMUS-midterm.pptx
+++ b/pptx/midterm/REMUS-midterm.pptx
@@ -777,7 +777,7 @@
             <a:lvl1pPr algn="ctr">
               <a:defRPr sz="4800" b="1" baseline="0">
                 <a:solidFill>
-                  <a:srgbClr val="183B56"/>
+                  <a:srgbClr val="C00000"/>
                 </a:solidFill>
                 <a:latin typeface="Arial" panose="020B0502040504020204" pitchFamily="34" charset="0"/>
                 <a:ea typeface="Noto Sans CJK SC" panose="020B0500000000000000" pitchFamily="34" charset="-122"/>
@@ -900,7 +900,7 @@
           </a:prstGeom>
           <a:ln w="19050">
             <a:solidFill>
-              <a:srgbClr val="008C95"/>
+              <a:srgbClr val="C55A11"/>
             </a:solidFill>
           </a:ln>
         </p:spPr>
@@ -943,7 +943,7 @@
           </a:prstGeom>
           <a:ln w="19050">
             <a:solidFill>
-              <a:srgbClr val="008C95"/>
+              <a:srgbClr val="C55A11"/>
             </a:solidFill>
           </a:ln>
         </p:spPr>
@@ -1109,7 +1109,7 @@
             <a:lvl1pPr>
               <a:defRPr sz="3200" b="1" baseline="0">
                 <a:solidFill>
-                  <a:srgbClr val="183B56"/>
+                  <a:srgbClr val="C00000"/>
                 </a:solidFill>
                 <a:latin typeface="Arial" panose="020B0502040504020204" pitchFamily="34" charset="0"/>
                 <a:ea typeface="Noto Sans CJK SC" panose="020B0500000000000000" pitchFamily="34" charset="-122"/>
@@ -1357,7 +1357,7 @@
           </a:prstGeom>
           <a:ln w="19050">
             <a:solidFill>
-              <a:srgbClr val="008C95"/>
+              <a:srgbClr val="C55A11"/>
             </a:solidFill>
           </a:ln>
         </p:spPr>
@@ -1400,7 +1400,7 @@
           </a:prstGeom>
           <a:ln w="19050">
             <a:solidFill>
-              <a:srgbClr val="008C95"/>
+              <a:srgbClr val="C55A11"/>
             </a:solidFill>
           </a:ln>
         </p:spPr>
@@ -1480,7 +1480,7 @@
             <a:lvl1pPr algn="ctr">
               <a:defRPr sz="4800" b="1" baseline="0">
                 <a:solidFill>
-                  <a:srgbClr val="183B56"/>
+                  <a:srgbClr val="C00000"/>
                 </a:solidFill>
                 <a:latin typeface="Arial" panose="020B0502040504020204" pitchFamily="34" charset="0"/>
                 <a:ea typeface="Noto Sans CJK SC" panose="020B0500000000000000" pitchFamily="34" charset="-122"/>
@@ -2358,7 +2358,7 @@
             <a:r>
               <a:rPr lang="en-US" altLang="zh-CN" dirty="0">
                 <a:solidFill>
-                  <a:srgbClr val="607184"/>
+                  <a:srgbClr val="898989"/>
                 </a:solidFill>
                 <a:latin typeface="Arial" panose="020B0502040504020204" pitchFamily="34" charset="0"/>
                 <a:ea typeface="Noto Sans CJK SC" panose="020B0500000000000000" pitchFamily="34" charset="-122"/>
@@ -3197,7 +3197,7 @@
             <a:r>
               <a:rPr kumimoji="1" lang="zh-CN" altLang="en-US" sz="2400" b="1" dirty="0">
                 <a:solidFill>
-                  <a:srgbClr val="183B56"/>
+                  <a:srgbClr val="C00000"/>
                 </a:solidFill>
                 <a:latin typeface="Arial" panose="020B0502040504020204" pitchFamily="34" charset="0"/>
                 <a:ea typeface="Noto Sans CJK SC" panose="020B0500000000000000" pitchFamily="34" charset="-122"/>
@@ -3538,7 +3538,7 @@
             <a:r>
               <a:rPr lang="en-US" altLang="zh-CN" dirty="0">
                 <a:solidFill>
-                  <a:srgbClr val="607184"/>
+                  <a:srgbClr val="898989"/>
                 </a:solidFill>
                 <a:latin typeface="Arial" panose="020B0502040504020204" pitchFamily="34" charset="0"/>
                 <a:ea typeface="Noto Sans CJK SC" panose="020B0500000000000000" pitchFamily="34" charset="-122"/>
@@ -4363,40 +4363,40 @@
   <a:themeElements>
     <a:clrScheme name="Office">
       <a:dk1>
-        <a:srgbClr val="20354A"/>
+        <a:srgbClr val="1F1F1F"/>
       </a:dk1>
       <a:lt1>
         <a:srgbClr val="FFFFFF"/>
       </a:lt1>
       <a:dk2>
-        <a:srgbClr val="183B56"/>
+        <a:srgbClr val="333333"/>
       </a:dk2>
       <a:lt2>
-        <a:srgbClr val="F1F5F8"/>
+        <a:srgbClr val="F5F5F5"/>
       </a:lt2>
       <a:accent1>
-        <a:srgbClr val="183B56"/>
+        <a:srgbClr val="C00000"/>
       </a:accent1>
       <a:accent2>
-        <a:srgbClr val="008C95"/>
+        <a:srgbClr val="70AD47"/>
       </a:accent2>
       <a:accent3>
-        <a:srgbClr val="DF973E"/>
+        <a:srgbClr val="ED7D31"/>
       </a:accent3>
       <a:accent4>
-        <a:srgbClr val="EAF4F3"/>
+        <a:srgbClr val="F1F7EC"/>
       </a:accent4>
       <a:accent5>
-        <a:srgbClr val="607184"/>
+        <a:srgbClr val="898989"/>
       </a:accent5>
       <a:accent6>
-        <a:srgbClr val="F1F5F8"/>
+        <a:srgbClr val="F5F5F5"/>
       </a:accent6>
       <a:hlink>
-        <a:srgbClr val="008C95"/>
+        <a:srgbClr val="70AD47"/>
       </a:hlink>
       <a:folHlink>
-        <a:srgbClr val="183B56"/>
+        <a:srgbClr val="C00000"/>
       </a:folHlink>
     </a:clrScheme>
     <a:fontScheme name="Times New Roman-Arial">

</xml_diff>